<commit_message>
Strategy deck: 'Draft · for approval' instead of 'awaiting your approval'
Co-Authored-By: Claude Opus 5.5 <noreply@anthropic.com>
</commit_message>
<xml_diff>
--- a/outputs/presentations/Silverleaf_Lead_Generation_Strategy_2026-10-12.pptx
+++ b/outputs/presentations/Silverleaf_Lead_Generation_Strategy_2026-10-12.pptx
@@ -22319,7 +22319,7 @@
                 </a:solidFill>
                 <a:latin typeface="Georgia"/>
               </a:rPr>
-              <a:t>What happens after the offer, and how we will know. A draft awaiting your approval.</a:t>
+              <a:t>What happens after the offer, and how we will know. A draft awaiting approval.</a:t>
             </a:r>
           </a:p>
         </p:txBody>
@@ -22579,7 +22579,7 @@
                 </a:solidFill>
                 <a:latin typeface="Arial"/>
               </a:rPr>
-              <a:t>DRAFT · AWAITING YOUR APPROVAL</a:t>
+              <a:t>DRAFT · FOR APPROVAL</a:t>
             </a:r>
           </a:p>
         </p:txBody>
@@ -24755,7 +24755,7 @@
                 </a:solidFill>
                 <a:latin typeface="Arial"/>
               </a:rPr>
-              <a:t>DRAFT · AWAITING YOUR APPROVAL</a:t>
+              <a:t>DRAFT · FOR APPROVAL</a:t>
             </a:r>
           </a:p>
         </p:txBody>
@@ -26940,7 +26940,7 @@
                 </a:solidFill>
                 <a:latin typeface="Arial"/>
               </a:rPr>
-              <a:t>DRAFT · AWAITING YOUR APPROVAL</a:t>
+              <a:t>DRAFT · FOR APPROVAL</a:t>
             </a:r>
           </a:p>
         </p:txBody>
@@ -29526,7 +29526,7 @@
                 </a:solidFill>
                 <a:latin typeface="Arial"/>
               </a:rPr>
-              <a:t>The partnership pipeline is a draft awaiting your approval, with 22 open questions and a recommendation for each. Nothing is sent automatically; a person sends every message.</a:t>
+              <a:t>The partnership pipeline is a draft awaiting approval, with 22 open questions and a recommendation for each. Nothing is sent automatically; a person sends every message.</a:t>
             </a:r>
           </a:p>
         </p:txBody>
@@ -31004,7 +31004,7 @@
                 </a:solidFill>
                 <a:latin typeface="Arial"/>
               </a:rPr>
-              <a:t>DRAFT · AWAITING YOUR APPROVAL</a:t>
+              <a:t>DRAFT · FOR APPROVAL</a:t>
             </a:r>
           </a:p>
         </p:txBody>
@@ -33229,7 +33229,7 @@
                 </a:solidFill>
                 <a:latin typeface="Arial"/>
               </a:rPr>
-              <a:t>DRAFT · AWAITING YOUR APPROVAL</a:t>
+              <a:t>DRAFT · FOR APPROVAL</a:t>
             </a:r>
           </a:p>
         </p:txBody>
@@ -35991,7 +35991,7 @@
                 </a:solidFill>
                 <a:latin typeface="Arial"/>
               </a:rPr>
-              <a:t>DRAFT · AWAITING YOUR APPROVAL</a:t>
+              <a:t>DRAFT · FOR APPROVAL</a:t>
             </a:r>
           </a:p>
         </p:txBody>
@@ -38665,7 +38665,7 @@
                 </a:solidFill>
                 <a:latin typeface="Arial"/>
               </a:rPr>
-              <a:t>DRAFT · AWAITING YOUR APPROVAL</a:t>
+              <a:t>DRAFT · FOR APPROVAL</a:t>
             </a:r>
           </a:p>
         </p:txBody>
@@ -41306,7 +41306,7 @@
                 </a:solidFill>
                 <a:latin typeface="Arial"/>
               </a:rPr>
-              <a:t>DRAFT · AWAITING YOUR APPROVAL</a:t>
+              <a:t>DRAFT · FOR APPROVAL</a:t>
             </a:r>
           </a:p>
         </p:txBody>
@@ -43859,7 +43859,7 @@
                 </a:solidFill>
                 <a:latin typeface="Arial"/>
               </a:rPr>
-              <a:t>DRAFT · AWAITING YOUR APPROVAL</a:t>
+              <a:t>DRAFT · FOR APPROVAL</a:t>
             </a:r>
           </a:p>
         </p:txBody>
@@ -46534,7 +46534,7 @@
                 </a:solidFill>
                 <a:latin typeface="Arial"/>
               </a:rPr>
-              <a:t>DRAFT · AWAITING YOUR APPROVAL</a:t>
+              <a:t>DRAFT · FOR APPROVAL</a:t>
             </a:r>
           </a:p>
         </p:txBody>
@@ -49531,7 +49531,7 @@
                 </a:solidFill>
                 <a:latin typeface="Arial"/>
               </a:rPr>
-              <a:t>DRAFT · AWAITING YOUR APPROVAL</a:t>
+              <a:t>DRAFT · FOR APPROVAL</a:t>
             </a:r>
           </a:p>
         </p:txBody>
@@ -51638,7 +51638,7 @@
                 </a:solidFill>
                 <a:latin typeface="Arial"/>
               </a:rPr>
-              <a:t>DRAFT · AWAITING YOUR APPROVAL</a:t>
+              <a:t>DRAFT · FOR APPROVAL</a:t>
             </a:r>
           </a:p>
         </p:txBody>
@@ -52775,7 +52775,7 @@
                 </a:solidFill>
                 <a:latin typeface="Arial"/>
               </a:rPr>
-              <a:t>DRAFT · AWAITING YOUR APPROVAL</a:t>
+              <a:t>DRAFT · FOR APPROVAL</a:t>
             </a:r>
           </a:p>
         </p:txBody>
@@ -54316,7 +54316,7 @@
                 </a:solidFill>
                 <a:latin typeface="Arial"/>
               </a:rPr>
-              <a:t>DRAFT · AWAITING YOUR APPROVAL</a:t>
+              <a:t>DRAFT · FOR APPROVAL</a:t>
             </a:r>
           </a:p>
         </p:txBody>

</xml_diff>

<commit_message>
Strategy deck next steps: preliminary campaign with the high-confidence band; paid Google Maps (Places) access
Co-Authored-By: Claude Opus 5.5 <noreply@anthropic.com>
</commit_message>
<xml_diff>
--- a/outputs/presentations/Silverleaf_Lead_Generation_Strategy_2026-10-12.pptx
+++ b/outputs/presentations/Silverleaf_Lead_Generation_Strategy_2026-10-12.pptx
@@ -29899,7 +29899,7 @@
                 </a:solidFill>
                 <a:latin typeface="Arial"/>
               </a:rPr>
-              <a:t>Apply the high-direct research lessons</a:t>
+              <a:t>Run a preliminary campaign</a:t>
             </a:r>
           </a:p>
         </p:txBody>
@@ -29934,7 +29934,7 @@
                 </a:solidFill>
                 <a:latin typeface="Arial"/>
               </a:rPr>
-              <a:t>Deep-crawl own sites before any search; directories pay for decision-makers; vacancy notices only for banks and larger employers; skip repeated name searches and @domain queries for small operators; try annual reports for P1 employers.</a:t>
+              <a:t>Start with the high-confidence band: the leads whose decision-maker we can reach directly or by name. Their replies test the message, the offer and the follow-up rhythm before the wider rollout.</a:t>
             </a:r>
           </a:p>
         </p:txBody>
@@ -30031,7 +30031,7 @@
                 </a:solidFill>
                 <a:latin typeface="Arial"/>
               </a:rPr>
-              <a:t>Approve sponsorship follow-up copy</a:t>
+              <a:t>Pay for Google Maps access</a:t>
             </a:r>
           </a:p>
         </p:txBody>
@@ -30066,7 +30066,7 @@
                 </a:solidFill>
                 <a:latin typeface="Arial"/>
               </a:rPr>
-              <a:t>The 14 sponsorship drafts to employers, and the funder follow-ups, need approved copy before they can go out.</a:t>
+              <a:t>A paid Google Cloud account with the Maps (Places) service gives us addresses, phone numbers, websites and exact locations for every lead at scale, in place of one-by-one lookups.</a:t>
             </a:r>
           </a:p>
         </p:txBody>

</xml_diff>

<commit_message>
Strategy deck next steps: five steps (opt-in and materials, tracking, preliminary campaign with introducers and pilot councils, Google Maps listings, Google Maps access)
Co-Authored-By: Claude Opus 5.5 <noreply@anthropic.com>
</commit_message>
<xml_diff>
--- a/outputs/presentations/Silverleaf_Lead_Generation_Strategy_2026-10-12.pptx
+++ b/outputs/presentations/Silverleaf_Lead_Generation_Strategy_2026-10-12.pptx
@@ -20470,7 +20470,7 @@
                 </a:solidFill>
                 <a:latin typeface="Arial"/>
               </a:rPr>
-              <a:t>Four steps from design to delivery</a:t>
+              <a:t>Five steps from design to delivery</a:t>
             </a:r>
           </a:p>
         </p:txBody>
@@ -20483,7 +20483,7 @@
         </p:nvSpPr>
         <p:spPr>
           <a:xfrm>
-            <a:off x="548640" y="1508760"/>
+            <a:off x="548640" y="1417320"/>
             <a:ext cx="457200" cy="402336"/>
           </a:xfrm>
           <a:prstGeom prst="hexagon">
@@ -20524,7 +20524,7 @@
         </p:nvSpPr>
         <p:spPr>
           <a:xfrm>
-            <a:off x="1188720" y="1371600"/>
+            <a:off x="1188720" y="1280160"/>
             <a:ext cx="3291840" cy="685800"/>
           </a:xfrm>
           <a:prstGeom prst="rect">
@@ -20546,7 +20546,7 @@
                 </a:solidFill>
                 <a:latin typeface="Arial"/>
               </a:rPr>
-              <a:t>Build the tracking</a:t>
+              <a:t>Get the opt-in and materials ready</a:t>
             </a:r>
           </a:p>
         </p:txBody>
@@ -20559,7 +20559,7 @@
         </p:nvSpPr>
         <p:spPr>
           <a:xfrm>
-            <a:off x="4572000" y="1371600"/>
+            <a:off x="4572000" y="1280160"/>
             <a:ext cx="7068312" cy="685800"/>
           </a:xfrm>
           <a:prstGeom prst="rect">
@@ -20581,7 +20581,7 @@
                 </a:solidFill>
                 <a:latin typeface="Arial"/>
               </a:rPr>
-              <a:t>Stages, dates, next actions, outcomes and partner reports for every deal in all three lead lists, with a pipeline sheet in each workbook and map filters by stage.</a:t>
+              <a:t>The data protection officer approves the sign-up form and consent wording. Then the pamphlet with its QR sign-up, the one-page offer sheet and a short staff-session deck, with Kiswahili versions for savings groups and community meetings.</a:t>
             </a:r>
           </a:p>
         </p:txBody>
@@ -20594,7 +20594,7 @@
         </p:nvCxnSpPr>
         <p:spPr>
           <a:xfrm>
-            <a:off x="1188720" y="2304288"/>
+            <a:off x="1188720" y="2167128"/>
             <a:ext cx="10451592" cy="0"/>
           </a:xfrm>
           <a:prstGeom prst="line">
@@ -20615,7 +20615,7 @@
         </p:nvSpPr>
         <p:spPr>
           <a:xfrm>
-            <a:off x="548640" y="2624328"/>
+            <a:off x="548640" y="2350008"/>
             <a:ext cx="457200" cy="402336"/>
           </a:xfrm>
           <a:prstGeom prst="hexagon">
@@ -20656,7 +20656,7 @@
         </p:nvSpPr>
         <p:spPr>
           <a:xfrm>
-            <a:off x="1188720" y="2487168"/>
+            <a:off x="1188720" y="2212848"/>
             <a:ext cx="3291840" cy="685800"/>
           </a:xfrm>
           <a:prstGeom prst="rect">
@@ -20678,7 +20678,7 @@
                 </a:solidFill>
                 <a:latin typeface="Arial"/>
               </a:rPr>
-              <a:t>Fix the Google Maps listings</a:t>
+              <a:t>Build the tracking</a:t>
             </a:r>
           </a:p>
         </p:txBody>
@@ -20691,7 +20691,7 @@
         </p:nvSpPr>
         <p:spPr>
           <a:xfrm>
-            <a:off x="4572000" y="2487168"/>
+            <a:off x="4572000" y="2212848"/>
             <a:ext cx="7068312" cy="685800"/>
           </a:xfrm>
           <a:prstGeom prst="rect">
@@ -20713,7 +20713,7 @@
                 </a:solidFill>
                 <a:latin typeface="Arial"/>
               </a:rPr>
-              <a:t>Move the Kijenge pin, correct or remove the two stray listings, and add Arusha City (Sakina) and Boma Ng'ombe from the website pins.</a:t>
+              <a:t>Stages, dates, next actions, outcomes and partner reports for every deal in all three lead lists, with a pipeline sheet in each workbook and map filters by stage.</a:t>
             </a:r>
           </a:p>
         </p:txBody>
@@ -20726,7 +20726,7 @@
         </p:nvCxnSpPr>
         <p:spPr>
           <a:xfrm>
-            <a:off x="1188720" y="3419856"/>
+            <a:off x="1188720" y="3099816"/>
             <a:ext cx="10451592" cy="0"/>
           </a:xfrm>
           <a:prstGeom prst="line">
@@ -20747,7 +20747,7 @@
         </p:nvSpPr>
         <p:spPr>
           <a:xfrm>
-            <a:off x="548640" y="3739896"/>
+            <a:off x="548640" y="3282696"/>
             <a:ext cx="457200" cy="402336"/>
           </a:xfrm>
           <a:prstGeom prst="hexagon">
@@ -20788,7 +20788,7 @@
         </p:nvSpPr>
         <p:spPr>
           <a:xfrm>
-            <a:off x="1188720" y="3602736"/>
+            <a:off x="1188720" y="3145536"/>
             <a:ext cx="3291840" cy="685800"/>
           </a:xfrm>
           <a:prstGeom prst="rect">
@@ -20823,7 +20823,7 @@
         </p:nvSpPr>
         <p:spPr>
           <a:xfrm>
-            <a:off x="4572000" y="3602736"/>
+            <a:off x="4572000" y="3145536"/>
             <a:ext cx="7068312" cy="685800"/>
           </a:xfrm>
           <a:prstGeom prst="rect">
@@ -20845,7 +20845,7 @@
                 </a:solidFill>
                 <a:latin typeface="Arial"/>
               </a:rPr>
-              <a:t>Start with the high-confidence band: the leads whose decision-maker we can reach directly or by name. Their replies test the message, the offer and the follow-up rhythm before the wider rollout.</a:t>
+              <a:t>The high-confidence band, the introducers (one yes from TATO, the hotels association or a chamber reaches dozens of employers) and the four pilot councils, booked before the January intake closes in December.</a:t>
             </a:r>
           </a:p>
         </p:txBody>
@@ -20858,7 +20858,7 @@
         </p:nvCxnSpPr>
         <p:spPr>
           <a:xfrm>
-            <a:off x="1188720" y="4535424"/>
+            <a:off x="1188720" y="4032504"/>
             <a:ext cx="10451592" cy="0"/>
           </a:xfrm>
           <a:prstGeom prst="line">
@@ -20879,7 +20879,7 @@
         </p:nvSpPr>
         <p:spPr>
           <a:xfrm>
-            <a:off x="548640" y="4855464"/>
+            <a:off x="548640" y="4215384"/>
             <a:ext cx="457200" cy="402336"/>
           </a:xfrm>
           <a:prstGeom prst="hexagon">
@@ -20920,7 +20920,7 @@
         </p:nvSpPr>
         <p:spPr>
           <a:xfrm>
-            <a:off x="1188720" y="4718304"/>
+            <a:off x="1188720" y="4078224"/>
             <a:ext cx="3291840" cy="685800"/>
           </a:xfrm>
           <a:prstGeom prst="rect">
@@ -20942,6 +20942,117 @@
                 </a:solidFill>
                 <a:latin typeface="Arial"/>
               </a:rPr>
+              <a:t>Fix the Google Maps listings</a:t>
+            </a:r>
+          </a:p>
+        </p:txBody>
+      </p:sp>
+      <p:sp>
+        <p:nvSpPr>
+          <p:cNvPr id="18" name="TextBox 17"/>
+          <p:cNvSpPr txBox="1"/>
+          <p:nvPr/>
+        </p:nvSpPr>
+        <p:spPr>
+          <a:xfrm>
+            <a:off x="4572000" y="4078224"/>
+            <a:ext cx="7068312" cy="685800"/>
+          </a:xfrm>
+          <a:prstGeom prst="rect">
+            <a:avLst/>
+          </a:prstGeom>
+          <a:noFill/>
+        </p:spPr>
+        <p:txBody>
+          <a:bodyPr wrap="square" lIns="0" tIns="0" rIns="0" bIns="0" anchor="ctr">
+            <a:spAutoFit/>
+          </a:bodyPr>
+          <a:lstStyle/>
+          <a:p>
+            <a:pPr algn="l"/>
+            <a:r>
+              <a:rPr sz="1100" b="0" i="0">
+                <a:solidFill>
+                  <a:srgbClr val="000000"/>
+                </a:solidFill>
+                <a:latin typeface="Arial"/>
+              </a:rPr>
+              <a:t>Move the Kijenge pin, correct or remove the two stray listings, and add Arusha City (Sakina) and Boma Ng'ombe from the website pins.</a:t>
+            </a:r>
+          </a:p>
+        </p:txBody>
+      </p:sp>
+      <p:sp>
+        <p:nvSpPr>
+          <p:cNvPr id="16" name="Hexagon 19"/>
+          <p:cNvSpPr/>
+          <p:nvPr/>
+        </p:nvSpPr>
+        <p:spPr>
+          <a:xfrm>
+            <a:off x="548640" y="5148072"/>
+            <a:ext cx="457200" cy="402336"/>
+          </a:xfrm>
+          <a:prstGeom prst="hexagon">
+            <a:avLst>
+              <a:gd name="adj" fmla="val 25000"/>
+              <a:gd name="vf" fmla="val 115470"/>
+            </a:avLst>
+          </a:prstGeom>
+          <a:solidFill>
+            <a:srgbClr val="002368"/>
+          </a:solidFill>
+          <a:ln>
+            <a:noFill/>
+          </a:ln>
+        </p:spPr>
+        <p:txBody>
+          <a:bodyPr rtlCol="0" anchor="ctr" wrap="square" lIns="0" tIns="0" rIns="0" bIns="0"/>
+          <a:lstStyle/>
+          <a:p>
+            <a:pPr algn="ctr"/>
+            <a:r>
+              <a:rPr sz="1100" b="1" i="0">
+                <a:solidFill>
+                  <a:srgbClr val="FFFFFF"/>
+                </a:solidFill>
+                <a:latin typeface="Arial"/>
+              </a:rPr>
+              <a:t>05</a:t>
+            </a:r>
+          </a:p>
+        </p:txBody>
+      </p:sp>
+      <p:sp>
+        <p:nvSpPr>
+          <p:cNvPr id="17" name="TextBox 20"/>
+          <p:cNvSpPr txBox="1"/>
+          <p:nvPr/>
+        </p:nvSpPr>
+        <p:spPr>
+          <a:xfrm>
+            <a:off x="1188720" y="5010912"/>
+            <a:ext cx="3291840" cy="685800"/>
+          </a:xfrm>
+          <a:prstGeom prst="rect">
+            <a:avLst/>
+          </a:prstGeom>
+          <a:noFill/>
+        </p:spPr>
+        <p:txBody>
+          <a:bodyPr wrap="square" lIns="0" tIns="0" rIns="0" bIns="0" anchor="ctr">
+            <a:spAutoFit/>
+          </a:bodyPr>
+          <a:lstStyle/>
+          <a:p>
+            <a:pPr algn="l"/>
+            <a:r>
+              <a:rPr sz="1400" b="1" i="0">
+                <a:solidFill>
+                  <a:srgbClr val="002368"/>
+                </a:solidFill>
+                <a:latin typeface="Arial"/>
+              </a:rPr>
               <a:t>Pay for Google Maps access</a:t>
             </a:r>
           </a:p>
@@ -20949,13 +21060,13 @@
       </p:sp>
       <p:sp>
         <p:nvSpPr>
-          <p:cNvPr id="18" name="TextBox 17"/>
-          <p:cNvSpPr txBox="1"/>
-          <p:nvPr/>
-        </p:nvSpPr>
-        <p:spPr>
-          <a:xfrm>
-            <a:off x="4572000" y="4718304"/>
+          <p:cNvPr id="18" name="TextBox 21"/>
+          <p:cNvSpPr txBox="1"/>
+          <p:nvPr/>
+        </p:nvSpPr>
+        <p:spPr>
+          <a:xfrm>
+            <a:off x="4572000" y="5010912"/>
             <a:ext cx="7068312" cy="685800"/>
           </a:xfrm>
           <a:prstGeom prst="rect">
@@ -20982,6 +21093,27 @@
           </a:p>
         </p:txBody>
       </p:sp>
+      <p:cxnSp>
+        <p:nvCxnSpPr>
+          <p:cNvPr id="15" name="Connector 22"/>
+          <p:cNvCxnSpPr/>
+          <p:nvPr/>
+        </p:nvCxnSpPr>
+        <p:spPr>
+          <a:xfrm>
+            <a:off x="1188720" y="4965192"/>
+            <a:ext cx="10451592" cy="0"/>
+          </a:xfrm>
+          <a:prstGeom prst="line">
+            <a:avLst/>
+          </a:prstGeom>
+          <a:ln w="9525">
+            <a:solidFill>
+              <a:srgbClr val="ECECEC"/>
+            </a:solidFill>
+          </a:ln>
+        </p:spPr>
+      </p:cxnSp>
       <p:pic>
         <p:nvPicPr>
           <p:cNvPr id="19" name="Picture 18" descr="image3.png"/>

</xml_diff>

<commit_message>
Strategy deck: offer terms cited to the 2025 Proposed Fees & Discounts schedule with a Finance check before the first send; the 2027 Finance condition removed (slides 15, 31, 32, sources)
Co-Authored-By: Claude Opus 5.5 <noreply@anthropic.com>
</commit_message>
<xml_diff>
--- a/outputs/presentations/Silverleaf_Lead_Generation_Strategy_2026-10-12.pptx
+++ b/outputs/presentations/Silverleaf_Lead_Generation_Strategy_2026-10-12.pptx
@@ -1616,7 +1616,7 @@
           <a:lstStyle/>
           <a:p>
             <a:r>
-              <a:t>Register status: Finance confirms that each term applies to the 2027 school year before any message that states it is sent (2027 enrolment plan tasks A1 and A2). OF05 referral package has expired; no referral rewards until a 2027 scheme is approved. OF08 (Rivertrees, 40%) is for Rivertrees only and is the model for a proposal after a meeting. No offer guarantees a place, transport route or capacity.</a:t>
+              <a:t>Offer terms come from Silverleaf's 2025 Proposed Fees &amp; Discounts schedule (Summary of discounts offered); Finance checks them once before the first send. OF05 referral package has expired; no referral rewards until a new scheme is approved. OF08 (Rivertrees, 40%) is for Rivertrees only and is the model for a proposal after a meeting. No offer guarantees a place, transport route or capacity.</a:t>
             </a:r>
           </a:p>
         </p:txBody>
@@ -10569,7 +10569,7 @@
                           </a:solidFill>
                           <a:latin typeface="Arial"/>
                         </a:rPr>
-                        <a:t>Finance to confirm for 2027</a:t>
+                        <a:t>None</a:t>
                       </a:r>
                     </a:p>
                   </a:txBody>
@@ -10983,7 +10983,7 @@
                           </a:solidFill>
                           <a:latin typeface="Arial"/>
                         </a:rPr>
-                        <a:t>All primary-age children; Finance for 2027</a:t>
+                        <a:t>All primary-age children placed</a:t>
                       </a:r>
                     </a:p>
                   </a:txBody>
@@ -11259,7 +11259,7 @@
                           </a:solidFill>
                           <a:latin typeface="Arial"/>
                         </a:rPr>
-                        <a:t>Finance to confirm for 2027</a:t>
+                        <a:t>None</a:t>
                       </a:r>
                     </a:p>
                   </a:txBody>
@@ -11514,6 +11514,41 @@
                 <a:latin typeface="Georgia"/>
               </a:rPr>
               <a:t>15</a:t>
+            </a:r>
+          </a:p>
+        </p:txBody>
+      </p:sp>
+      <p:sp>
+        <p:nvSpPr>
+          <p:cNvPr id="6" name="Offer source note"/>
+          <p:cNvSpPr txBox="1"/>
+          <p:nvPr/>
+        </p:nvSpPr>
+        <p:spPr>
+          <a:xfrm>
+            <a:off x="548640" y="5797296"/>
+            <a:ext cx="11091672" cy="274320"/>
+          </a:xfrm>
+          <a:prstGeom prst="rect">
+            <a:avLst/>
+          </a:prstGeom>
+          <a:noFill/>
+        </p:spPr>
+        <p:txBody>
+          <a:bodyPr wrap="square" lIns="0" tIns="0" rIns="0" bIns="0" anchor="ctr">
+            <a:spAutoFit/>
+          </a:bodyPr>
+          <a:lstStyle/>
+          <a:p>
+            <a:pPr algn="l"/>
+            <a:r>
+              <a:rPr sz="1100" b="0" i="1">
+                <a:solidFill>
+                  <a:srgbClr val="818283"/>
+                </a:solidFill>
+                <a:latin typeface="Arial"/>
+              </a:rPr>
+              <a:t>Offer terms come from Silverleaf's 2025 Proposed Fees &amp; Discounts schedule. Confirm with Finance before the first send.</a:t>
             </a:r>
           </a:p>
         </p:txBody>
@@ -42297,7 +42332,7 @@
                           </a:solidFill>
                           <a:latin typeface="Arial"/>
                         </a:rPr>
-                        <a:t>proposal date, offer IDs, Finance confirmation; incentive register ID, approval and expiry; win type, approver, renewal date</a:t>
+                        <a:t>proposal date, offer IDs, Finance check; incentive register ID, approval and expiry; win type, approver, renewal date</a:t>
                       </a:r>
                     </a:p>
                   </a:txBody>
@@ -43344,7 +43379,7 @@
                           </a:solidFill>
                           <a:latin typeface="Arial"/>
                         </a:rPr>
-                        <a:t>Coord S1–S7 and government letters; Adm from opt-in; campus head hosts; Finance confirms terms; CEO signs</a:t>
+                        <a:t>Coord S1–S7 and government letters; Adm from opt-in; campus head hosts; Finance checks terms before the first send; CEO signs</a:t>
                       </a:r>
                     </a:p>
                   </a:txBody>
@@ -43864,7 +43899,7 @@
                           </a:solidFill>
                           <a:latin typeface="Arial"/>
                         </a:rPr>
-                        <a:t>A thank-you letter and termly totals; no reward until the 2027 referral scheme</a:t>
+                        <a:t>A thank-you letter and termly totals; no reward until a new referral scheme</a:t>
                       </a:r>
                     </a:p>
                   </a:txBody>

</xml_diff>

<commit_message>
VICOBA T5 deck: SACCOS and VICOBA rows on slide 15, savings groups on slide 9, VICOBA sources on slide 6, E6 VICOBA branch on A4, VICOBA register gap on A12
Figures from a post-merge master copy, with their queries in the sources file (new section 'VICOBA savings groups'); the sources file's mis-encoded dashes and arrows repaired; the slide map names the VICOBA slides. Headline lead totals stay the 12 October snapshot.

Co-Authored-By: Claude Opus 5.5 <noreply@anthropic.com>
</commit_message>
<xml_diff>
--- a/outputs/presentations/Silverleaf_Lead_Generation_Strategy_2026-10-12.pptx
+++ b/outputs/presentations/Silverleaf_Lead_Generation_Strategy_2026-10-12.pptx
@@ -10446,7 +10446,7 @@
         </p:nvGraphicFramePr>
         <p:xfrm>
           <a:off x="548640" y="1298448"/>
-          <a:ext cx="11091672" cy="4492752"/>
+          <a:ext cx="11091672" cy="4443984"/>
         </p:xfrm>
         <a:graphic>
           <a:graphicData uri="http://schemas.openxmlformats.org/drawingml/2006/table">
@@ -10484,7 +10484,7 @@
                   </a:extLst>
                 </a:gridCol>
               </a:tblGrid>
-              <a:tr h="548640">
+              <a:tr h="320040">
                 <a:tc>
                   <a:txBody>
                     <a:bodyPr/>
@@ -10627,7 +10627,7 @@
                   </a:ext>
                 </a:extLst>
               </a:tr>
-              <a:tr h="548640">
+              <a:tr h="667512">
                 <a:tc>
                   <a:txBody>
                     <a:bodyPr/>
@@ -10794,7 +10794,7 @@
                   </a:ext>
                 </a:extLst>
               </a:tr>
-              <a:tr h="548640">
+              <a:tr h="493776">
                 <a:tc>
                   <a:txBody>
                     <a:bodyPr/>
@@ -10961,7 +10961,7 @@
                   </a:ext>
                 </a:extLst>
               </a:tr>
-              <a:tr h="548640">
+              <a:tr h="493776">
                 <a:tc>
                   <a:txBody>
                     <a:bodyPr/>
@@ -10974,7 +10974,7 @@
                           </a:solidFill>
                           <a:latin typeface="Arial"/>
                         </a:rPr>
-                        <a:t>Savings groups</a:t>
+                        <a:t>SACCOS</a:t>
                       </a:r>
                     </a:p>
                   </a:txBody>
@@ -11128,7 +11128,174 @@
                   </a:ext>
                 </a:extLst>
               </a:tr>
-              <a:tr h="548640">
+              <a:tr h="493776">
+                <a:tc>
+                  <a:txBody>
+                    <a:bodyPr/>
+                    <a:lstStyle/>
+                    <a:p>
+                      <a:r>
+                        <a:rPr sz="950" b="1" i="0">
+                          <a:solidFill>
+                            <a:srgbClr val="002368"/>
+                          </a:solidFill>
+                          <a:latin typeface="Arial"/>
+                        </a:rPr>
+                        <a:t>VICOBA groups</a:t>
+                      </a:r>
+                    </a:p>
+                  </a:txBody>
+                  <a:tcPr marL="0" marR="54864" marT="36576" marB="36576" anchor="ctr">
+                    <a:lnL w="0">
+                      <a:noFill/>
+                    </a:lnL>
+                    <a:lnR w="0">
+                      <a:noFill/>
+                    </a:lnR>
+                    <a:lnT w="9525" cap="flat" cmpd="sng" algn="ctr">
+                      <a:solidFill>
+                        <a:srgbClr val="ECECEC"/>
+                      </a:solidFill>
+                      <a:prstDash val="solid"/>
+                      <a:round/>
+                      <a:headEnd type="none" w="med" len="med"/>
+                      <a:tailEnd type="none" w="med" len="med"/>
+                    </a:lnT>
+                    <a:lnB w="9525">
+                      <a:solidFill>
+                        <a:srgbClr val="ECECEC"/>
+                      </a:solidFill>
+                    </a:lnB>
+                    <a:noFill/>
+                  </a:tcPr>
+                </a:tc>
+                <a:tc>
+                  <a:txBody>
+                    <a:bodyPr/>
+                    <a:lstStyle/>
+                    <a:p>
+                      <a:r>
+                        <a:rPr sz="950" b="0" i="0">
+                          <a:solidFill>
+                            <a:srgbClr val="000000"/>
+                          </a:solidFill>
+                          <a:latin typeface="Arial"/>
+                        </a:rPr>
+                        <a:t>A Kiswahili request to the committee for 10–15 minutes at a weekly meeting, handed over by its introducer</a:t>
+                      </a:r>
+                    </a:p>
+                  </a:txBody>
+                  <a:tcPr marL="54864" marR="54864" marT="36576" marB="36576" anchor="ctr">
+                    <a:lnL w="0">
+                      <a:noFill/>
+                    </a:lnL>
+                    <a:lnR w="0">
+                      <a:noFill/>
+                    </a:lnR>
+                    <a:lnT w="9525" cap="flat" cmpd="sng" algn="ctr">
+                      <a:solidFill>
+                        <a:srgbClr val="ECECEC"/>
+                      </a:solidFill>
+                      <a:prstDash val="solid"/>
+                      <a:round/>
+                      <a:headEnd type="none" w="med" len="med"/>
+                      <a:tailEnd type="none" w="med" len="med"/>
+                    </a:lnT>
+                    <a:lnB w="9525">
+                      <a:solidFill>
+                        <a:srgbClr val="ECECEC"/>
+                      </a:solidFill>
+                    </a:lnB>
+                    <a:noFill/>
+                  </a:tcPr>
+                </a:tc>
+                <a:tc>
+                  <a:txBody>
+                    <a:bodyPr/>
+                    <a:lstStyle/>
+                    <a:p>
+                      <a:r>
+                        <a:rPr sz="950" b="0" i="0">
+                          <a:solidFill>
+                            <a:srgbClr val="000000"/>
+                          </a:solidFill>
+                          <a:latin typeface="Arial"/>
+                        </a:rPr>
+                        <a:t>Family offer, plus the group rate (OF07): 7% per student at 50, 12% at 100, 17% at 150</a:t>
+                      </a:r>
+                    </a:p>
+                  </a:txBody>
+                  <a:tcPr marL="54864" marR="54864" marT="36576" marB="36576" anchor="ctr">
+                    <a:lnL w="0">
+                      <a:noFill/>
+                    </a:lnL>
+                    <a:lnR w="0">
+                      <a:noFill/>
+                    </a:lnR>
+                    <a:lnT w="9525" cap="flat" cmpd="sng" algn="ctr">
+                      <a:solidFill>
+                        <a:srgbClr val="ECECEC"/>
+                      </a:solidFill>
+                      <a:prstDash val="solid"/>
+                      <a:round/>
+                      <a:headEnd type="none" w="med" len="med"/>
+                      <a:tailEnd type="none" w="med" len="med"/>
+                    </a:lnT>
+                    <a:lnB w="9525">
+                      <a:solidFill>
+                        <a:srgbClr val="ECECEC"/>
+                      </a:solidFill>
+                    </a:lnB>
+                    <a:noFill/>
+                  </a:tcPr>
+                </a:tc>
+                <a:tc>
+                  <a:txBody>
+                    <a:bodyPr/>
+                    <a:lstStyle/>
+                    <a:p>
+                      <a:r>
+                        <a:rPr sz="950" b="0" i="0">
+                          <a:solidFill>
+                            <a:srgbClr val="000000"/>
+                          </a:solidFill>
+                          <a:latin typeface="Arial"/>
+                        </a:rPr>
+                        <a:t>Kiswahili review and an introducer route</a:t>
+                      </a:r>
+                    </a:p>
+                  </a:txBody>
+                  <a:tcPr marL="54864" marR="54864" marT="36576" marB="36576" anchor="ctr">
+                    <a:lnL w="0">
+                      <a:noFill/>
+                    </a:lnL>
+                    <a:lnR w="0">
+                      <a:noFill/>
+                    </a:lnR>
+                    <a:lnT w="9525" cap="flat" cmpd="sng" algn="ctr">
+                      <a:solidFill>
+                        <a:srgbClr val="ECECEC"/>
+                      </a:solidFill>
+                      <a:prstDash val="solid"/>
+                      <a:round/>
+                      <a:headEnd type="none" w="med" len="med"/>
+                      <a:tailEnd type="none" w="med" len="med"/>
+                    </a:lnT>
+                    <a:lnB w="9525">
+                      <a:solidFill>
+                        <a:srgbClr val="ECECEC"/>
+                      </a:solidFill>
+                    </a:lnB>
+                    <a:noFill/>
+                  </a:tcPr>
+                </a:tc>
+                <a:extLst>
+                  <a:ext uri="{0D108BD9-81ED-4DB2-BD59-A6C34878D82A}">
+                    <a16:rowId xmlns:a16="http://schemas.microsoft.com/office/drawing/2014/main" val="10003"/>
+                  </a:ext>
+                </a:extLst>
+              </a:tr>
+              <a:tr h="493776">
                 <a:tc>
                   <a:txBody>
                     <a:bodyPr/>
@@ -11295,7 +11462,7 @@
                   </a:ext>
                 </a:extLst>
               </a:tr>
-              <a:tr h="548640">
+              <a:tr h="493776">
                 <a:tc>
                   <a:txBody>
                     <a:bodyPr/>
@@ -11462,7 +11629,7 @@
                   </a:ext>
                 </a:extLst>
               </a:tr>
-              <a:tr h="548640">
+              <a:tr h="493776">
                 <a:tc>
                   <a:txBody>
                     <a:bodyPr/>
@@ -11629,7 +11796,7 @@
                   </a:ext>
                 </a:extLst>
               </a:tr>
-              <a:tr h="548640">
+              <a:tr h="493776">
                 <a:tc>
                   <a:txBody>
                     <a:bodyPr/>
@@ -11902,7 +12069,7 @@
         </p:nvSpPr>
         <p:spPr>
           <a:xfrm>
-            <a:off x="548640" y="5797296"/>
+            <a:off x="548640" y="5788152"/>
             <a:ext cx="11091672" cy="274320"/>
           </a:xfrm>
           <a:prstGeom prst="rect">
@@ -30907,7 +31074,7 @@
                 </a:solidFill>
                 <a:latin typeface="Arial"/>
               </a:rPr>
-              <a:t>Savings groups (SACCOS)</a:t>
+              <a:t>Savings groups (SACCOS, VICOBA)</a:t>
             </a:r>
           </a:p>
         </p:txBody>
@@ -30942,7 +31109,7 @@
                 </a:solidFill>
                 <a:latin typeface="Arial"/>
               </a:rPr>
-              <a:t>Employer-based 48, community 67, unclassified 2 · 117 (1 ready)</a:t>
+              <a:t>SACCOS: employer-based 48, community 67, unclassified 2 · 117 (1 ready). VICOBA: 5 (0 ready), women's groups first</a:t>
             </a:r>
           </a:p>
         </p:txBody>
@@ -31562,7 +31729,7 @@
                 </a:solidFill>
                 <a:latin typeface="Arial"/>
               </a:rPr>
-              <a:t>code SAC</a:t>
+              <a:t>code SAC or VIC</a:t>
             </a:r>
           </a:p>
         </p:txBody>
@@ -31768,7 +31935,7 @@
                 </a:solidFill>
                 <a:latin typeface="Arial"/>
               </a:rPr>
-              <a:t>116 no email: call the chair or secretary first</a:t>
+              <a:t>SACCOS: 116 no email, call the chair or secretary first</a:t>
             </a:r>
           </a:p>
         </p:txBody>
@@ -31782,7 +31949,7 @@
         <p:spPr>
           <a:xfrm>
             <a:off x="2075688" y="5550408"/>
-            <a:ext cx="9564624" cy="365760"/>
+            <a:ext cx="9564624" cy="548640"/>
           </a:xfrm>
           <a:prstGeom prst="rect">
             <a:avLst/>
@@ -31803,7 +31970,7 @@
                 </a:solidFill>
                 <a:latin typeface="Arial"/>
               </a:rPr>
-              <a:t>Sign-ups count toward the 50 / 100 / 150 group-rate thresholds as totals. No loan, payroll or subsidy claim.</a:t>
+              <a:t>Sign-ups count toward the 50 / 100 / 150 group-rate thresholds as totals. No loan, payroll or subsidy claim. VICOBA: the introducer request comes first (NGO programme, bank branch, or the ward officer after the council's introduction), then the committee and a 10–15 minute Kiswahili talk at a weekly meeting; silent → dormant until the next savings cycle.</a:t>
             </a:r>
           </a:p>
         </p:txBody>
@@ -48250,7 +48417,7 @@
         <p:spPr>
           <a:xfrm>
             <a:off x="548640" y="1325880"/>
-            <a:ext cx="5449824" cy="2176272"/>
+            <a:ext cx="3569208" cy="2176272"/>
           </a:xfrm>
           <a:prstGeom prst="roundRect">
             <a:avLst>
@@ -48319,7 +48486,7 @@
         <p:spPr>
           <a:xfrm>
             <a:off x="1417319" y="1527048"/>
-            <a:ext cx="4389120" cy="292608"/>
+            <a:ext cx="2517649" cy="292608"/>
           </a:xfrm>
           <a:prstGeom prst="rect">
             <a:avLst/>
@@ -48354,7 +48521,7 @@
         <p:spPr>
           <a:xfrm>
             <a:off x="777240" y="2011680"/>
-            <a:ext cx="5029200" cy="822960"/>
+            <a:ext cx="3148584" cy="822960"/>
           </a:xfrm>
           <a:prstGeom prst="rect">
             <a:avLst/>
@@ -48389,7 +48556,7 @@
         <p:spPr>
           <a:xfrm>
             <a:off x="777240" y="2880360"/>
-            <a:ext cx="4992624" cy="457200"/>
+            <a:ext cx="3112008" cy="457200"/>
           </a:xfrm>
           <a:prstGeom prst="roundRect">
             <a:avLst>
@@ -48423,7 +48590,7 @@
         <p:spPr>
           <a:xfrm>
             <a:off x="914400" y="2880360"/>
-            <a:ext cx="4754880" cy="457200"/>
+            <a:ext cx="2883408" cy="457200"/>
           </a:xfrm>
           <a:prstGeom prst="rect">
             <a:avLst/>
@@ -48466,8 +48633,8 @@
         </p:nvSpPr>
         <p:spPr>
           <a:xfrm>
-            <a:off x="6190488" y="1325880"/>
-            <a:ext cx="5449824" cy="2176272"/>
+            <a:off x="4309872" y="1325880"/>
+            <a:ext cx="3569208" cy="2176272"/>
           </a:xfrm>
           <a:prstGeom prst="roundRect">
             <a:avLst>
@@ -48500,7 +48667,7 @@
         </p:nvSpPr>
         <p:spPr>
           <a:xfrm>
-            <a:off x="6419088" y="1490472"/>
+            <a:off x="4538472" y="1490472"/>
             <a:ext cx="731520" cy="457200"/>
           </a:xfrm>
           <a:prstGeom prst="rect">
@@ -48535,8 +48702,8 @@
         </p:nvSpPr>
         <p:spPr>
           <a:xfrm>
-            <a:off x="7059168" y="1527048"/>
-            <a:ext cx="4389120" cy="292608"/>
+            <a:off x="5178551" y="1527048"/>
+            <a:ext cx="2517649" cy="292608"/>
           </a:xfrm>
           <a:prstGeom prst="rect">
             <a:avLst/>
@@ -48570,8 +48737,8 @@
         </p:nvSpPr>
         <p:spPr>
           <a:xfrm>
-            <a:off x="6419088" y="2011680"/>
-            <a:ext cx="5029200" cy="822960"/>
+            <a:off x="4538472" y="2011680"/>
+            <a:ext cx="3148584" cy="822960"/>
           </a:xfrm>
           <a:prstGeom prst="rect">
             <a:avLst/>
@@ -48605,8 +48772,8 @@
         </p:nvSpPr>
         <p:spPr>
           <a:xfrm>
-            <a:off x="6419088" y="2880360"/>
-            <a:ext cx="4992624" cy="457200"/>
+            <a:off x="4538472" y="2880360"/>
+            <a:ext cx="3112008" cy="457200"/>
           </a:xfrm>
           <a:prstGeom prst="roundRect">
             <a:avLst>
@@ -48639,8 +48806,8 @@
         </p:nvSpPr>
         <p:spPr>
           <a:xfrm>
-            <a:off x="6556248" y="2880360"/>
-            <a:ext cx="4754880" cy="457200"/>
+            <a:off x="4675632" y="2880360"/>
+            <a:ext cx="2883408" cy="457200"/>
           </a:xfrm>
           <a:prstGeom prst="rect">
             <a:avLst/>
@@ -48683,8 +48850,8 @@
         </p:nvSpPr>
         <p:spPr>
           <a:xfrm>
-            <a:off x="548640" y="3657600"/>
-            <a:ext cx="5449824" cy="2176272"/>
+            <a:off x="8071104" y="1325880"/>
+            <a:ext cx="3569208" cy="2176272"/>
           </a:xfrm>
           <a:prstGeom prst="roundRect">
             <a:avLst>
@@ -48717,7 +48884,7 @@
         </p:nvSpPr>
         <p:spPr>
           <a:xfrm>
-            <a:off x="777240" y="3822191"/>
+            <a:off x="8299704" y="1490472"/>
             <a:ext cx="731520" cy="457200"/>
           </a:xfrm>
           <a:prstGeom prst="rect">
@@ -48752,8 +48919,8 @@
         </p:nvSpPr>
         <p:spPr>
           <a:xfrm>
-            <a:off x="1417319" y="3858768"/>
-            <a:ext cx="4389120" cy="292608"/>
+            <a:off x="8939783" y="1527048"/>
+            <a:ext cx="2517649" cy="292608"/>
           </a:xfrm>
           <a:prstGeom prst="rect">
             <a:avLst/>
@@ -48787,8 +48954,8 @@
         </p:nvSpPr>
         <p:spPr>
           <a:xfrm>
-            <a:off x="777240" y="4343400"/>
-            <a:ext cx="5029200" cy="822960"/>
+            <a:off x="8299704" y="2011680"/>
+            <a:ext cx="3148584" cy="822960"/>
           </a:xfrm>
           <a:prstGeom prst="rect">
             <a:avLst/>
@@ -48822,8 +48989,8 @@
         </p:nvSpPr>
         <p:spPr>
           <a:xfrm>
-            <a:off x="777240" y="5212080"/>
-            <a:ext cx="4992624" cy="457200"/>
+            <a:off x="8299704" y="2880360"/>
+            <a:ext cx="3112008" cy="457200"/>
           </a:xfrm>
           <a:prstGeom prst="roundRect">
             <a:avLst>
@@ -48856,8 +49023,8 @@
         </p:nvSpPr>
         <p:spPr>
           <a:xfrm>
-            <a:off x="914400" y="5212080"/>
-            <a:ext cx="4754880" cy="457200"/>
+            <a:off x="8436864" y="2880360"/>
+            <a:ext cx="2883408" cy="457200"/>
           </a:xfrm>
           <a:prstGeom prst="rect">
             <a:avLst/>
@@ -48900,7 +49067,7 @@
         </p:nvSpPr>
         <p:spPr>
           <a:xfrm>
-            <a:off x="6190488" y="3657600"/>
+            <a:off x="548640" y="3657600"/>
             <a:ext cx="5449824" cy="2176272"/>
           </a:xfrm>
           <a:prstGeom prst="roundRect">
@@ -48928,13 +49095,47 @@
       </p:sp>
       <p:sp>
         <p:nvSpPr>
+          <p:cNvPr id="32" name="Rounded Rectangle 21 copy 32"/>
+          <p:cNvSpPr/>
+          <p:nvPr/>
+        </p:nvSpPr>
+        <p:spPr>
+          <a:xfrm>
+            <a:off x="6190488" y="3657600"/>
+            <a:ext cx="5449824" cy="2176272"/>
+          </a:xfrm>
+          <a:prstGeom prst="roundRect">
+            <a:avLst>
+              <a:gd name="adj" fmla="val 2941"/>
+            </a:avLst>
+          </a:prstGeom>
+          <a:solidFill>
+            <a:srgbClr val="FFFFFF"/>
+          </a:solidFill>
+          <a:ln w="12700">
+            <a:solidFill>
+              <a:srgbClr val="D9ECF9"/>
+            </a:solidFill>
+          </a:ln>
+        </p:spPr>
+        <p:txBody>
+          <a:bodyPr rtlCol="0" anchor="ctr"/>
+          <a:lstStyle/>
+          <a:p>
+            <a:pPr algn="ctr"/>
+            <a:endParaRPr/>
+          </a:p>
+        </p:txBody>
+      </p:sp>
+      <p:sp>
+        <p:nvSpPr>
           <p:cNvPr id="23" name="TextBox 22"/>
           <p:cNvSpPr txBox="1"/>
           <p:nvPr/>
         </p:nvSpPr>
         <p:spPr>
           <a:xfrm>
-            <a:off x="6419088" y="3822191"/>
+            <a:off x="777240" y="3822192"/>
             <a:ext cx="731520" cy="457200"/>
           </a:xfrm>
           <a:prstGeom prst="rect">
@@ -48963,14 +49164,49 @@
       </p:sp>
       <p:sp>
         <p:nvSpPr>
+          <p:cNvPr id="33" name="TextBox 22 copy 33"/>
+          <p:cNvSpPr txBox="1"/>
+          <p:nvPr/>
+        </p:nvSpPr>
+        <p:spPr>
+          <a:xfrm>
+            <a:off x="6419088" y="3822192"/>
+            <a:ext cx="731520" cy="457200"/>
+          </a:xfrm>
+          <a:prstGeom prst="rect">
+            <a:avLst/>
+          </a:prstGeom>
+          <a:noFill/>
+        </p:spPr>
+        <p:txBody>
+          <a:bodyPr wrap="square" lIns="0" tIns="0" rIns="0" bIns="0" anchor="t">
+            <a:spAutoFit/>
+          </a:bodyPr>
+          <a:lstStyle/>
+          <a:p>
+            <a:pPr algn="l"/>
+            <a:r>
+              <a:rPr sz="2000" b="0" i="0">
+                <a:solidFill>
+                  <a:srgbClr val="80BFEC"/>
+                </a:solidFill>
+                <a:latin typeface="Georgia"/>
+              </a:rPr>
+              <a:t>05</a:t>
+            </a:r>
+          </a:p>
+        </p:txBody>
+      </p:sp>
+      <p:sp>
+        <p:nvSpPr>
           <p:cNvPr id="24" name="TextBox 23"/>
           <p:cNvSpPr txBox="1"/>
           <p:nvPr/>
         </p:nvSpPr>
         <p:spPr>
           <a:xfrm>
-            <a:off x="7059168" y="3858768"/>
-            <a:ext cx="4389120" cy="292608"/>
+            <a:off x="1417319" y="3858768"/>
+            <a:ext cx="4398265" cy="292608"/>
           </a:xfrm>
           <a:prstGeom prst="rect">
             <a:avLst/>
@@ -48998,7 +49234,77 @@
       </p:sp>
       <p:sp>
         <p:nvSpPr>
+          <p:cNvPr id="34" name="TextBox 23 copy 34"/>
+          <p:cNvSpPr txBox="1"/>
+          <p:nvPr/>
+        </p:nvSpPr>
+        <p:spPr>
+          <a:xfrm>
+            <a:off x="7059167" y="3858768"/>
+            <a:ext cx="4398265" cy="292608"/>
+          </a:xfrm>
+          <a:prstGeom prst="rect">
+            <a:avLst/>
+          </a:prstGeom>
+          <a:noFill/>
+        </p:spPr>
+        <p:txBody>
+          <a:bodyPr wrap="square" lIns="0" tIns="0" rIns="0" bIns="0" anchor="t">
+            <a:spAutoFit/>
+          </a:bodyPr>
+          <a:lstStyle/>
+          <a:p>
+            <a:pPr algn="l"/>
+            <a:r>
+              <a:rPr sz="1300" b="1" i="0">
+                <a:solidFill>
+                  <a:srgbClr val="002368"/>
+                </a:solidFill>
+                <a:latin typeface="Arial"/>
+              </a:rPr>
+              <a:t>No public register of VICOBA groups</a:t>
+            </a:r>
+          </a:p>
+        </p:txBody>
+      </p:sp>
+      <p:sp>
+        <p:nvSpPr>
           <p:cNvPr id="25" name="TextBox 24"/>
+          <p:cNvSpPr txBox="1"/>
+          <p:nvPr/>
+        </p:nvSpPr>
+        <p:spPr>
+          <a:xfrm>
+            <a:off x="777240" y="4343400"/>
+            <a:ext cx="5029200" cy="822960"/>
+          </a:xfrm>
+          <a:prstGeom prst="rect">
+            <a:avLst/>
+          </a:prstGeom>
+          <a:noFill/>
+        </p:spPr>
+        <p:txBody>
+          <a:bodyPr wrap="square" lIns="0" tIns="0" rIns="0" bIns="0" anchor="t">
+            <a:spAutoFit/>
+          </a:bodyPr>
+          <a:lstStyle/>
+          <a:p>
+            <a:pPr algn="l"/>
+            <a:r>
+              <a:rPr sz="1050" b="0" i="0">
+                <a:solidFill>
+                  <a:srgbClr val="000000"/>
+                </a:solidFill>
+                <a:latin typeface="Arial"/>
+              </a:rPr>
+              <a:t>Each ward is one reference point, because no ward boundaries are mapped here, so its distance can be 1–5 km off.</a:t>
+            </a:r>
+          </a:p>
+        </p:txBody>
+      </p:sp>
+      <p:sp>
+        <p:nvSpPr>
+          <p:cNvPr id="35" name="TextBox 24 copy 35"/>
           <p:cNvSpPr txBox="1"/>
           <p:nvPr/>
         </p:nvSpPr>
@@ -49026,7 +49332,7 @@
                 </a:solidFill>
                 <a:latin typeface="Arial"/>
               </a:rPr>
-              <a:t>Each ward is one reference point, because no ward boundaries are mapped here, so its distance can be 1–5 km off.</a:t>
+              <a:t>Groups are known to ward community development officers, NGO programmes and bank branches. 5 groups are on file; 5 more council and NGO reports give totals only (106 groups), which stay counts, not records.</a:t>
             </a:r>
           </a:p>
         </p:txBody>
@@ -49039,7 +49345,7 @@
         </p:nvSpPr>
         <p:spPr>
           <a:xfrm>
-            <a:off x="6419088" y="5212080"/>
+            <a:off x="777240" y="5212080"/>
             <a:ext cx="4992624" cy="457200"/>
           </a:xfrm>
           <a:prstGeom prst="roundRect">
@@ -49067,14 +49373,92 @@
       </p:sp>
       <p:sp>
         <p:nvSpPr>
+          <p:cNvPr id="36" name="Rounded Rectangle 25 copy 36"/>
+          <p:cNvSpPr/>
+          <p:nvPr/>
+        </p:nvSpPr>
+        <p:spPr>
+          <a:xfrm>
+            <a:off x="6419088" y="5212080"/>
+            <a:ext cx="4992624" cy="457200"/>
+          </a:xfrm>
+          <a:prstGeom prst="roundRect">
+            <a:avLst>
+              <a:gd name="adj" fmla="val 14000"/>
+            </a:avLst>
+          </a:prstGeom>
+          <a:solidFill>
+            <a:srgbClr val="D9ECF9"/>
+          </a:solidFill>
+          <a:ln w="12700">
+            <a:solidFill>
+              <a:srgbClr val="D9ECF9"/>
+            </a:solidFill>
+          </a:ln>
+        </p:spPr>
+        <p:txBody>
+          <a:bodyPr rtlCol="0" anchor="ctr"/>
+          <a:lstStyle/>
+          <a:p>
+            <a:pPr algn="ctr"/>
+            <a:endParaRPr/>
+          </a:p>
+        </p:txBody>
+      </p:sp>
+      <p:sp>
+        <p:nvSpPr>
           <p:cNvPr id="27" name="TextBox 26"/>
           <p:cNvSpPr txBox="1"/>
           <p:nvPr/>
         </p:nvSpPr>
         <p:spPr>
           <a:xfrm>
+            <a:off x="914400" y="5212080"/>
+            <a:ext cx="4764024" cy="457200"/>
+          </a:xfrm>
+          <a:prstGeom prst="rect">
+            <a:avLst/>
+          </a:prstGeom>
+          <a:noFill/>
+        </p:spPr>
+        <p:txBody>
+          <a:bodyPr wrap="square" lIns="0" tIns="0" rIns="0" bIns="0" anchor="ctr">
+            <a:spAutoFit/>
+          </a:bodyPr>
+          <a:lstStyle/>
+          <a:p>
+            <a:pPr algn="l"/>
+            <a:r>
+              <a:rPr sz="1050" b="1" i="0">
+                <a:solidFill>
+                  <a:srgbClr val="002368"/>
+                </a:solidFill>
+                <a:latin typeface="Arial"/>
+              </a:rPr>
+              <a:t>Fix: </a:t>
+            </a:r>
+            <a:r>
+              <a:rPr sz="1050" b="0" i="0">
+                <a:solidFill>
+                  <a:srgbClr val="000000"/>
+                </a:solidFill>
+                <a:latin typeface="Arial"/>
+              </a:rPr>
+              <a:t>Use the official ward boundaries.</a:t>
+            </a:r>
+          </a:p>
+        </p:txBody>
+      </p:sp>
+      <p:sp>
+        <p:nvSpPr>
+          <p:cNvPr id="37" name="TextBox 26 copy 37"/>
+          <p:cNvSpPr txBox="1"/>
+          <p:nvPr/>
+        </p:nvSpPr>
+        <p:spPr>
+          <a:xfrm>
             <a:off x="6556248" y="5212080"/>
-            <a:ext cx="4754880" cy="457200"/>
+            <a:ext cx="4764024" cy="457200"/>
           </a:xfrm>
           <a:prstGeom prst="rect">
             <a:avLst/>
@@ -49104,7 +49488,7 @@
                 </a:solidFill>
                 <a:latin typeface="Arial"/>
               </a:rPr>
-              <a:t>Use the official ward boundaries.</a:t>
+              <a:t>Each introducer names its groups after the council's introduction; every group is reconfirmed within 12 months.</a:t>
             </a:r>
           </a:p>
         </p:txBody>
@@ -52812,37 +53196,16 @@
           </a:p>
         </p:txBody>
       </p:sp>
-      <p:cxnSp>
-        <p:nvCxnSpPr>
-          <p:cNvPr id="23" name="Connector 22"/>
-          <p:cNvCxnSpPr/>
-          <p:nvPr/>
-        </p:nvCxnSpPr>
-        <p:spPr>
-          <a:xfrm>
-            <a:off x="548640" y="2697480"/>
-            <a:ext cx="11091672" cy="0"/>
-          </a:xfrm>
-          <a:prstGeom prst="line">
-            <a:avLst/>
-          </a:prstGeom>
-          <a:ln w="9525">
-            <a:solidFill>
-              <a:srgbClr val="ECECEC"/>
-            </a:solidFill>
-          </a:ln>
-        </p:spPr>
-      </p:cxnSp>
-      <p:sp>
-        <p:nvSpPr>
-          <p:cNvPr id="24" name="Hexagon 23"/>
+      <p:sp>
+        <p:nvSpPr>
+          <p:cNvPr id="83" name="Hexagon 21 copy 83"/>
           <p:cNvSpPr/>
           <p:nvPr/>
         </p:nvSpPr>
         <p:spPr>
           <a:xfrm>
-            <a:off x="548640" y="2766060"/>
-            <a:ext cx="384048" cy="338328"/>
+            <a:off x="9025128" y="5248656"/>
+            <a:ext cx="274320" cy="246888"/>
           </a:xfrm>
           <a:prstGeom prst="hexagon">
             <a:avLst>
@@ -52862,167 +53225,19 @@
           <a:lstStyle/>
           <a:p>
             <a:pPr algn="ctr"/>
-            <a:r>
-              <a:rPr sz="1000" b="1" i="0">
-                <a:solidFill>
-                  <a:srgbClr val="FFFFFF"/>
-                </a:solidFill>
-                <a:latin typeface="Arial"/>
-              </a:rPr>
-              <a:t>2</a:t>
-            </a:r>
-          </a:p>
-        </p:txBody>
-      </p:sp>
-      <p:sp>
-        <p:nvSpPr>
-          <p:cNvPr id="25" name="TextBox 24"/>
-          <p:cNvSpPr txBox="1"/>
-          <p:nvPr/>
-        </p:nvSpPr>
-        <p:spPr>
-          <a:xfrm>
-            <a:off x="1051560" y="2729484"/>
-            <a:ext cx="2423160" cy="237744"/>
-          </a:xfrm>
-          <a:prstGeom prst="rect">
-            <a:avLst/>
-          </a:prstGeom>
-          <a:noFill/>
-        </p:spPr>
-        <p:txBody>
-          <a:bodyPr wrap="square" lIns="0" tIns="0" rIns="0" bIns="0" anchor="t">
-            <a:spAutoFit/>
-          </a:bodyPr>
-          <a:lstStyle/>
-          <a:p>
-            <a:pPr algn="l"/>
-            <a:r>
-              <a:rPr sz="1200" b="1" i="0">
-                <a:solidFill>
-                  <a:srgbClr val="002368"/>
-                </a:solidFill>
-                <a:latin typeface="Arial"/>
-              </a:rPr>
-              <a:t>TCDC</a:t>
-            </a:r>
-          </a:p>
-        </p:txBody>
-      </p:sp>
-      <p:sp>
-        <p:nvSpPr>
-          <p:cNvPr id="26" name="TextBox 25"/>
-          <p:cNvSpPr txBox="1"/>
-          <p:nvPr/>
-        </p:nvSpPr>
-        <p:spPr>
-          <a:xfrm>
-            <a:off x="1051560" y="2958084"/>
-            <a:ext cx="2423160" cy="201168"/>
-          </a:xfrm>
-          <a:prstGeom prst="rect">
-            <a:avLst/>
-          </a:prstGeom>
-          <a:noFill/>
-        </p:spPr>
-        <p:txBody>
-          <a:bodyPr wrap="square" lIns="0" tIns="0" rIns="0" bIns="0" anchor="t">
-            <a:spAutoFit/>
-          </a:bodyPr>
-          <a:lstStyle/>
-          <a:p>
-            <a:pPr algn="l"/>
-            <a:r>
-              <a:rPr sz="850" b="0" i="0">
-                <a:solidFill>
-                  <a:srgbClr val="818283"/>
-                </a:solidFill>
-                <a:latin typeface="Arial"/>
-              </a:rPr>
-              <a:t>Tanzania Cooperative Development Commission</a:t>
-            </a:r>
-          </a:p>
-        </p:txBody>
-      </p:sp>
-      <p:sp>
-        <p:nvSpPr>
-          <p:cNvPr id="27" name="TextBox 26"/>
-          <p:cNvSpPr txBox="1"/>
-          <p:nvPr/>
-        </p:nvSpPr>
-        <p:spPr>
-          <a:xfrm>
-            <a:off x="3520440" y="2729484"/>
-            <a:ext cx="1280160" cy="411480"/>
-          </a:xfrm>
-          <a:prstGeom prst="rect">
-            <a:avLst/>
-          </a:prstGeom>
-          <a:noFill/>
-        </p:spPr>
-        <p:txBody>
-          <a:bodyPr wrap="square" lIns="0" tIns="0" rIns="0" bIns="0" anchor="ctr">
-            <a:spAutoFit/>
-          </a:bodyPr>
-          <a:lstStyle/>
-          <a:p>
-            <a:pPr algn="l"/>
-            <a:r>
-              <a:rPr sz="2000" b="0" i="0">
-                <a:solidFill>
-                  <a:srgbClr val="002368"/>
-                </a:solidFill>
-                <a:latin typeface="Georgia"/>
-              </a:rPr>
-              <a:t>115</a:t>
-            </a:r>
-          </a:p>
-        </p:txBody>
-      </p:sp>
-      <p:sp>
-        <p:nvSpPr>
-          <p:cNvPr id="28" name="TextBox 27"/>
-          <p:cNvSpPr txBox="1"/>
-          <p:nvPr/>
-        </p:nvSpPr>
-        <p:spPr>
-          <a:xfrm>
-            <a:off x="4846320" y="2729484"/>
-            <a:ext cx="3703320" cy="411480"/>
-          </a:xfrm>
-          <a:prstGeom prst="rect">
-            <a:avLst/>
-          </a:prstGeom>
-          <a:noFill/>
-        </p:spPr>
-        <p:txBody>
-          <a:bodyPr wrap="square" lIns="0" tIns="0" rIns="0" bIns="0" anchor="ctr">
-            <a:spAutoFit/>
-          </a:bodyPr>
-          <a:lstStyle/>
-          <a:p>
-            <a:pPr algn="l"/>
-            <a:r>
-              <a:rPr sz="1000" b="0" i="0">
-                <a:solidFill>
-                  <a:srgbClr val="000000"/>
-                </a:solidFill>
-                <a:latin typeface="Arial"/>
-              </a:rPr>
-              <a:t>licensed savings groups (SACCOS) around the campuses</a:t>
-            </a:r>
-          </a:p>
-        </p:txBody>
-      </p:sp>
-      <p:sp>
-        <p:nvSpPr>
-          <p:cNvPr id="29" name="Hexagon 28"/>
+            <a:endParaRPr/>
+          </a:p>
+        </p:txBody>
+      </p:sp>
+      <p:sp>
+        <p:nvSpPr>
+          <p:cNvPr id="82" name="Hexagon 21 copy 82"/>
           <p:cNvSpPr/>
           <p:nvPr/>
         </p:nvSpPr>
         <p:spPr>
           <a:xfrm>
-            <a:off x="9025128" y="2802636"/>
+            <a:off x="9025128" y="4759452"/>
             <a:ext cx="274320" cy="246888"/>
           </a:xfrm>
           <a:prstGeom prst="hexagon">
@@ -53049,6 +53264,241 @@
       </p:sp>
       <p:cxnSp>
         <p:nvCxnSpPr>
+          <p:cNvPr id="23" name="Connector 22"/>
+          <p:cNvCxnSpPr/>
+          <p:nvPr/>
+        </p:nvCxnSpPr>
+        <p:spPr>
+          <a:xfrm>
+            <a:off x="548640" y="2697480"/>
+            <a:ext cx="11091672" cy="0"/>
+          </a:xfrm>
+          <a:prstGeom prst="line">
+            <a:avLst/>
+          </a:prstGeom>
+          <a:ln w="9525">
+            <a:solidFill>
+              <a:srgbClr val="ECECEC"/>
+            </a:solidFill>
+          </a:ln>
+        </p:spPr>
+      </p:cxnSp>
+      <p:sp>
+        <p:nvSpPr>
+          <p:cNvPr id="24" name="Hexagon 23"/>
+          <p:cNvSpPr/>
+          <p:nvPr/>
+        </p:nvSpPr>
+        <p:spPr>
+          <a:xfrm>
+            <a:off x="548640" y="2766060"/>
+            <a:ext cx="384048" cy="338328"/>
+          </a:xfrm>
+          <a:prstGeom prst="hexagon">
+            <a:avLst>
+              <a:gd name="adj" fmla="val 25000"/>
+              <a:gd name="vf" fmla="val 115470"/>
+            </a:avLst>
+          </a:prstGeom>
+          <a:solidFill>
+            <a:srgbClr val="002368"/>
+          </a:solidFill>
+          <a:ln>
+            <a:noFill/>
+          </a:ln>
+        </p:spPr>
+        <p:txBody>
+          <a:bodyPr wrap="square" lIns="0" tIns="0" rIns="0" bIns="0" rtlCol="0" anchor="ctr"/>
+          <a:lstStyle/>
+          <a:p>
+            <a:pPr algn="ctr"/>
+            <a:r>
+              <a:rPr sz="1000" b="1" i="0">
+                <a:solidFill>
+                  <a:srgbClr val="FFFFFF"/>
+                </a:solidFill>
+                <a:latin typeface="Arial"/>
+              </a:rPr>
+              <a:t>2</a:t>
+            </a:r>
+          </a:p>
+        </p:txBody>
+      </p:sp>
+      <p:sp>
+        <p:nvSpPr>
+          <p:cNvPr id="25" name="TextBox 24"/>
+          <p:cNvSpPr txBox="1"/>
+          <p:nvPr/>
+        </p:nvSpPr>
+        <p:spPr>
+          <a:xfrm>
+            <a:off x="1051560" y="2729484"/>
+            <a:ext cx="2423160" cy="237744"/>
+          </a:xfrm>
+          <a:prstGeom prst="rect">
+            <a:avLst/>
+          </a:prstGeom>
+          <a:noFill/>
+        </p:spPr>
+        <p:txBody>
+          <a:bodyPr wrap="square" lIns="0" tIns="0" rIns="0" bIns="0" anchor="t">
+            <a:spAutoFit/>
+          </a:bodyPr>
+          <a:lstStyle/>
+          <a:p>
+            <a:pPr algn="l"/>
+            <a:r>
+              <a:rPr sz="1200" b="1" i="0">
+                <a:solidFill>
+                  <a:srgbClr val="002368"/>
+                </a:solidFill>
+                <a:latin typeface="Arial"/>
+              </a:rPr>
+              <a:t>TCDC</a:t>
+            </a:r>
+          </a:p>
+        </p:txBody>
+      </p:sp>
+      <p:sp>
+        <p:nvSpPr>
+          <p:cNvPr id="26" name="TextBox 25"/>
+          <p:cNvSpPr txBox="1"/>
+          <p:nvPr/>
+        </p:nvSpPr>
+        <p:spPr>
+          <a:xfrm>
+            <a:off x="1051560" y="2958084"/>
+            <a:ext cx="2423160" cy="201168"/>
+          </a:xfrm>
+          <a:prstGeom prst="rect">
+            <a:avLst/>
+          </a:prstGeom>
+          <a:noFill/>
+        </p:spPr>
+        <p:txBody>
+          <a:bodyPr wrap="square" lIns="0" tIns="0" rIns="0" bIns="0" anchor="t">
+            <a:spAutoFit/>
+          </a:bodyPr>
+          <a:lstStyle/>
+          <a:p>
+            <a:pPr algn="l"/>
+            <a:r>
+              <a:rPr sz="850" b="0" i="0">
+                <a:solidFill>
+                  <a:srgbClr val="818283"/>
+                </a:solidFill>
+                <a:latin typeface="Arial"/>
+              </a:rPr>
+              <a:t>Tanzania Cooperative Development Commission</a:t>
+            </a:r>
+          </a:p>
+        </p:txBody>
+      </p:sp>
+      <p:sp>
+        <p:nvSpPr>
+          <p:cNvPr id="27" name="TextBox 26"/>
+          <p:cNvSpPr txBox="1"/>
+          <p:nvPr/>
+        </p:nvSpPr>
+        <p:spPr>
+          <a:xfrm>
+            <a:off x="3520440" y="2729484"/>
+            <a:ext cx="1280160" cy="411480"/>
+          </a:xfrm>
+          <a:prstGeom prst="rect">
+            <a:avLst/>
+          </a:prstGeom>
+          <a:noFill/>
+        </p:spPr>
+        <p:txBody>
+          <a:bodyPr wrap="square" lIns="0" tIns="0" rIns="0" bIns="0" anchor="ctr">
+            <a:spAutoFit/>
+          </a:bodyPr>
+          <a:lstStyle/>
+          <a:p>
+            <a:pPr algn="l"/>
+            <a:r>
+              <a:rPr sz="2000" b="0" i="0">
+                <a:solidFill>
+                  <a:srgbClr val="002368"/>
+                </a:solidFill>
+                <a:latin typeface="Georgia"/>
+              </a:rPr>
+              <a:t>115</a:t>
+            </a:r>
+          </a:p>
+        </p:txBody>
+      </p:sp>
+      <p:sp>
+        <p:nvSpPr>
+          <p:cNvPr id="28" name="TextBox 27"/>
+          <p:cNvSpPr txBox="1"/>
+          <p:nvPr/>
+        </p:nvSpPr>
+        <p:spPr>
+          <a:xfrm>
+            <a:off x="4846320" y="2729484"/>
+            <a:ext cx="3703320" cy="411480"/>
+          </a:xfrm>
+          <a:prstGeom prst="rect">
+            <a:avLst/>
+          </a:prstGeom>
+          <a:noFill/>
+        </p:spPr>
+        <p:txBody>
+          <a:bodyPr wrap="square" lIns="0" tIns="0" rIns="0" bIns="0" anchor="ctr">
+            <a:spAutoFit/>
+          </a:bodyPr>
+          <a:lstStyle/>
+          <a:p>
+            <a:pPr algn="l"/>
+            <a:r>
+              <a:rPr sz="1000" b="0" i="0">
+                <a:solidFill>
+                  <a:srgbClr val="000000"/>
+                </a:solidFill>
+                <a:latin typeface="Arial"/>
+              </a:rPr>
+              <a:t>licensed savings groups (SACCOS) around the campuses</a:t>
+            </a:r>
+          </a:p>
+        </p:txBody>
+      </p:sp>
+      <p:sp>
+        <p:nvSpPr>
+          <p:cNvPr id="29" name="Hexagon 28"/>
+          <p:cNvSpPr/>
+          <p:nvPr/>
+        </p:nvSpPr>
+        <p:spPr>
+          <a:xfrm>
+            <a:off x="9025128" y="2802636"/>
+            <a:ext cx="274320" cy="246888"/>
+          </a:xfrm>
+          <a:prstGeom prst="hexagon">
+            <a:avLst>
+              <a:gd name="adj" fmla="val 25000"/>
+              <a:gd name="vf" fmla="val 115470"/>
+            </a:avLst>
+          </a:prstGeom>
+          <a:solidFill>
+            <a:srgbClr val="002368"/>
+          </a:solidFill>
+          <a:ln>
+            <a:noFill/>
+          </a:ln>
+        </p:spPr>
+        <p:txBody>
+          <a:bodyPr wrap="square" lIns="0" tIns="0" rIns="0" bIns="0" rtlCol="0" anchor="ctr"/>
+          <a:lstStyle/>
+          <a:p>
+            <a:pPr algn="ctr"/>
+            <a:endParaRPr/>
+          </a:p>
+        </p:txBody>
+      </p:sp>
+      <p:cxnSp>
+        <p:nvCxnSpPr>
           <p:cNvPr id="30" name="Connector 29"/>
           <p:cNvCxnSpPr/>
           <p:nvPr/>
@@ -54081,7 +54531,7 @@
                 </a:solidFill>
                 <a:latin typeface="Arial"/>
               </a:rPr>
-              <a:t>register entries read; 285 match a welfare lead</a:t>
+              <a:t>register entries read; 285 match a welfare lead; 4 savings-group introducers</a:t>
             </a:r>
           </a:p>
         </p:txBody>
@@ -54316,7 +54766,7 @@
                 </a:solidFill>
                 <a:latin typeface="Arial"/>
               </a:rPr>
-              <a:t>offices: 9 councils, 7 districts, 3 regions and 129 wards</a:t>
+              <a:t>offices: 9 councils, 7 districts, 3 regions and 129 wards; council news names VICOBA groups</a:t>
             </a:r>
           </a:p>
         </p:txBody>
@@ -58337,7 +58787,7 @@
                 </a:solidFill>
                 <a:latin typeface="Georgia"/>
               </a:rPr>
-              <a:t>117</a:t>
+              <a:t>122</a:t>
             </a:r>
           </a:p>
         </p:txBody>
@@ -58372,7 +58822,7 @@
                 </a:solidFill>
                 <a:latin typeface="Arial"/>
               </a:rPr>
-              <a:t>savings groups (SACCOS): members, not staff, approached through the committee in Kiswahili</a:t>
+              <a:t>savings groups: members, not staff, approached through the committee in Kiswahili</a:t>
             </a:r>
           </a:p>
         </p:txBody>
@@ -58385,7 +58835,7 @@
         </p:nvSpPr>
         <p:spPr>
           <a:xfrm>
-            <a:off x="6519672" y="2377440"/>
+            <a:off x="6519672" y="2468880"/>
             <a:ext cx="731520" cy="457200"/>
           </a:xfrm>
           <a:prstGeom prst="rect">
@@ -58420,7 +58870,7 @@
         </p:nvSpPr>
         <p:spPr>
           <a:xfrm>
-            <a:off x="7269480" y="2395728"/>
+            <a:off x="7269480" y="2487168"/>
             <a:ext cx="4114800" cy="256032"/>
           </a:xfrm>
           <a:prstGeom prst="rect">
@@ -58449,13 +58899,83 @@
       </p:sp>
       <p:sp>
         <p:nvSpPr>
+          <p:cNvPr id="42" name="TextBox 26 copy 42"/>
+          <p:cNvSpPr txBox="1"/>
+          <p:nvPr/>
+        </p:nvSpPr>
+        <p:spPr>
+          <a:xfrm>
+            <a:off x="6519672" y="3657600"/>
+            <a:ext cx="4864608" cy="256032"/>
+          </a:xfrm>
+          <a:prstGeom prst="rect">
+            <a:avLst/>
+          </a:prstGeom>
+          <a:noFill/>
+        </p:spPr>
+        <p:txBody>
+          <a:bodyPr wrap="square" lIns="0" tIns="0" rIns="0" bIns="0" anchor="t">
+            <a:spAutoFit/>
+          </a:bodyPr>
+          <a:lstStyle/>
+          <a:p>
+            <a:pPr algn="l"/>
+            <a:r>
+              <a:rPr sz="1050" b="1" i="0">
+                <a:solidFill>
+                  <a:srgbClr val="FFC952"/>
+                </a:solidFill>
+                <a:latin typeface="Arial"/>
+              </a:rPr>
+              <a:t>5 VICOBA groups, reached through an introducer</a:t>
+            </a:r>
+          </a:p>
+        </p:txBody>
+      </p:sp>
+      <p:sp>
+        <p:nvSpPr>
+          <p:cNvPr id="41" name="TextBox 26 copy 41"/>
+          <p:cNvSpPr txBox="1"/>
+          <p:nvPr/>
+        </p:nvSpPr>
+        <p:spPr>
+          <a:xfrm>
+            <a:off x="6519672" y="2194560"/>
+            <a:ext cx="4864608" cy="256032"/>
+          </a:xfrm>
+          <a:prstGeom prst="rect">
+            <a:avLst/>
+          </a:prstGeom>
+          <a:noFill/>
+        </p:spPr>
+        <p:txBody>
+          <a:bodyPr wrap="square" lIns="0" tIns="0" rIns="0" bIns="0" anchor="t">
+            <a:spAutoFit/>
+          </a:bodyPr>
+          <a:lstStyle/>
+          <a:p>
+            <a:pPr algn="l"/>
+            <a:r>
+              <a:rPr sz="1050" b="1" i="0">
+                <a:solidFill>
+                  <a:srgbClr val="FFC952"/>
+                </a:solidFill>
+                <a:latin typeface="Arial"/>
+              </a:rPr>
+              <a:t>117 SACCOS: TCDC-licensed co-operatives</a:t>
+            </a:r>
+          </a:p>
+        </p:txBody>
+      </p:sp>
+      <p:sp>
+        <p:nvSpPr>
           <p:cNvPr id="28" name="TextBox 27"/>
           <p:cNvSpPr txBox="1"/>
           <p:nvPr/>
         </p:nvSpPr>
         <p:spPr>
           <a:xfrm>
-            <a:off x="7269480" y="2660904"/>
+            <a:off x="7269480" y="2724912"/>
             <a:ext cx="4114800" cy="411480"/>
           </a:xfrm>
           <a:prstGeom prst="rect">
@@ -58490,7 +59010,7 @@
         </p:nvSpPr>
         <p:spPr>
           <a:xfrm>
-            <a:off x="6519672" y="3154680"/>
+            <a:off x="6519672" y="3017520"/>
             <a:ext cx="731520" cy="457200"/>
           </a:xfrm>
           <a:prstGeom prst="rect">
@@ -58525,7 +59045,7 @@
         </p:nvSpPr>
         <p:spPr>
           <a:xfrm>
-            <a:off x="7269480" y="3172968"/>
+            <a:off x="7269480" y="3035808"/>
             <a:ext cx="4114800" cy="256032"/>
           </a:xfrm>
           <a:prstGeom prst="rect">
@@ -58560,7 +59080,7 @@
         </p:nvSpPr>
         <p:spPr>
           <a:xfrm>
-            <a:off x="7269480" y="3438144"/>
+            <a:off x="7269480" y="3273552"/>
             <a:ext cx="4114800" cy="411480"/>
           </a:xfrm>
           <a:prstGeom prst="rect">
@@ -58582,7 +59102,7 @@
                 </a:solidFill>
                 <a:latin typeface="Arial"/>
               </a:rPr>
-              <a:t>Broader membership; the members' meeting is the main event</a:t>
+              <a:t>Broader membership; the members' meeting is the main event (2 more from map data count here)</a:t>
             </a:r>
           </a:p>
         </p:txBody>
@@ -58624,13 +59144,48 @@
       </p:sp>
       <p:sp>
         <p:nvSpPr>
+          <p:cNvPr id="43" name="TextBox 31 copy 43"/>
+          <p:cNvSpPr txBox="1"/>
+          <p:nvPr/>
+        </p:nvSpPr>
+        <p:spPr>
+          <a:xfrm>
+            <a:off x="6519672" y="4462272"/>
+            <a:ext cx="731520" cy="457200"/>
+          </a:xfrm>
+          <a:prstGeom prst="rect">
+            <a:avLst/>
+          </a:prstGeom>
+          <a:noFill/>
+        </p:spPr>
+        <p:txBody>
+          <a:bodyPr wrap="square" lIns="0" tIns="0" rIns="0" bIns="0" anchor="t">
+            <a:spAutoFit/>
+          </a:bodyPr>
+          <a:lstStyle/>
+          <a:p>
+            <a:pPr algn="l"/>
+            <a:r>
+              <a:rPr sz="2200" b="0" i="0">
+                <a:solidFill>
+                  <a:srgbClr val="80BFEC"/>
+                </a:solidFill>
+                <a:latin typeface="Georgia"/>
+              </a:rPr>
+              <a:t>3</a:t>
+            </a:r>
+          </a:p>
+        </p:txBody>
+      </p:sp>
+      <p:sp>
+        <p:nvSpPr>
           <p:cNvPr id="33" name="TextBox 32"/>
           <p:cNvSpPr txBox="1"/>
           <p:nvPr/>
         </p:nvSpPr>
         <p:spPr>
           <a:xfrm>
-            <a:off x="7269480" y="3950207"/>
+            <a:off x="7269480" y="3950208"/>
             <a:ext cx="4114800" cy="256032"/>
           </a:xfrm>
           <a:prstGeom prst="rect">
@@ -58652,7 +59207,42 @@
                 </a:solidFill>
                 <a:latin typeface="Arial"/>
               </a:rPr>
-              <a:t>Unclassified (from map data)</a:t>
+              <a:t>Women's groups</a:t>
+            </a:r>
+          </a:p>
+        </p:txBody>
+      </p:sp>
+      <p:sp>
+        <p:nvSpPr>
+          <p:cNvPr id="44" name="TextBox 32 copy 44"/>
+          <p:cNvSpPr txBox="1"/>
+          <p:nvPr/>
+        </p:nvSpPr>
+        <p:spPr>
+          <a:xfrm>
+            <a:off x="7269480" y="4480560"/>
+            <a:ext cx="4114800" cy="256032"/>
+          </a:xfrm>
+          <a:prstGeom prst="rect">
+            <a:avLst/>
+          </a:prstGeom>
+          <a:noFill/>
+        </p:spPr>
+        <p:txBody>
+          <a:bodyPr wrap="square" lIns="0" tIns="0" rIns="0" bIns="0" anchor="t">
+            <a:spAutoFit/>
+          </a:bodyPr>
+          <a:lstStyle/>
+          <a:p>
+            <a:pPr algn="l"/>
+            <a:r>
+              <a:rPr sz="1150" b="1" i="0">
+                <a:solidFill>
+                  <a:srgbClr val="FFFFFF"/>
+                </a:solidFill>
+                <a:latin typeface="Arial"/>
+              </a:rPr>
+              <a:t>NGO-programme groups (VSLA)</a:t>
             </a:r>
           </a:p>
         </p:txBody>
@@ -58665,7 +59255,7 @@
         </p:nvSpPr>
         <p:spPr>
           <a:xfrm>
-            <a:off x="7269480" y="4215383"/>
+            <a:off x="7269480" y="4187952"/>
             <a:ext cx="4114800" cy="411480"/>
           </a:xfrm>
           <a:prstGeom prst="rect">
@@ -58687,7 +59277,42 @@
                 </a:solidFill>
                 <a:latin typeface="Arial"/>
               </a:rPr>
-              <a:t>Treated as community until the type is known</a:t>
+              <a:t>Worked first in every wave; the talk answers mothers' questions</a:t>
+            </a:r>
+          </a:p>
+        </p:txBody>
+      </p:sp>
+      <p:sp>
+        <p:nvSpPr>
+          <p:cNvPr id="45" name="TextBox 33 copy 45"/>
+          <p:cNvSpPr txBox="1"/>
+          <p:nvPr/>
+        </p:nvSpPr>
+        <p:spPr>
+          <a:xfrm>
+            <a:off x="7269480" y="4718304"/>
+            <a:ext cx="4114800" cy="411480"/>
+          </a:xfrm>
+          <a:prstGeom prst="rect">
+            <a:avLst/>
+          </a:prstGeom>
+          <a:noFill/>
+        </p:spPr>
+        <p:txBody>
+          <a:bodyPr wrap="square" lIns="0" tIns="0" rIns="0" bIns="0" anchor="t">
+            <a:spAutoFit/>
+          </a:bodyPr>
+          <a:lstStyle/>
+          <a:p>
+            <a:pPr algn="l"/>
+            <a:r>
+              <a:rPr sz="1000" b="0" i="0">
+                <a:solidFill>
+                  <a:srgbClr val="D9ECF9"/>
+                </a:solidFill>
+                <a:latin typeface="Arial"/>
+              </a:rPr>
+              <a:t>Introduced by the NGO that runs the programme</a:t>
             </a:r>
           </a:p>
         </p:txBody>
@@ -58700,7 +59325,7 @@
         </p:nvSpPr>
         <p:spPr>
           <a:xfrm>
-            <a:off x="6519672" y="4709160"/>
+            <a:off x="6519672" y="5093208"/>
             <a:ext cx="4800600" cy="777240"/>
           </a:xfrm>
           <a:prstGeom prst="roundRect">
@@ -58734,7 +59359,7 @@
         </p:nvSpPr>
         <p:spPr>
           <a:xfrm>
-            <a:off x="6702552" y="4892040"/>
+            <a:off x="6702552" y="5352288"/>
             <a:ext cx="292608" cy="256032"/>
           </a:xfrm>
           <a:prstGeom prst="hexagon">
@@ -58775,8 +59400,8 @@
         </p:nvSpPr>
         <p:spPr>
           <a:xfrm>
-            <a:off x="7132320" y="4828032"/>
-            <a:ext cx="4069080" cy="868680"/>
+            <a:off x="7132320" y="5157216"/>
+            <a:ext cx="4069080" cy="640080"/>
           </a:xfrm>
           <a:prstGeom prst="rect">
             <a:avLst/>
@@ -58797,7 +59422,7 @@
                 </a:solidFill>
                 <a:latin typeface="Arial"/>
               </a:rPr>
-              <a:t>116 of 117 publish no email. </a:t>
+              <a:t>SACCOS: </a:t>
             </a:r>
             <a:r>
               <a:rPr sz="1000" b="0" i="0">
@@ -58806,7 +59431,25 @@
                 </a:solidFill>
                 <a:latin typeface="Arial"/>
               </a:rPr>
-              <a:t>The committee chair or secretary is reached by phone, or by a Kiswahili letter delivered by hand.</a:t>
+              <a:t>116 of 117 publish no email; the chair or secretary is reached by phone or a Kiswahili letter. </a:t>
+            </a:r>
+            <a:r>
+              <a:rPr sz="1000" b="1" i="0">
+                <a:solidFill>
+                  <a:srgbClr val="002368"/>
+                </a:solidFill>
+                <a:latin typeface="Arial"/>
+              </a:rPr>
+              <a:t>VICOBA: </a:t>
+            </a:r>
+            <a:r>
+              <a:rPr sz="1000" b="0" i="0">
+                <a:solidFill>
+                  <a:srgbClr val="000000"/>
+                </a:solidFill>
+                <a:latin typeface="Arial"/>
+              </a:rPr>
+              <a:t>no group route of its own; 8 savings-group networks, 3 welfare-list NGOs and 4 banks' group accounts are the introducer routes on file.</a:t>
             </a:r>
           </a:p>
         </p:txBody>

</xml_diff>